<commit_message>
Fix BEA API integration: correct Results parsing and per-client industry selection
- Fix AttributeError in bea_client.py: Results is a list on success and a
  dict on error; replace broken .get("Results", {}).get("Error") chain with
  isinstance-guarded extraction
- Fix TimePeriod key: BEA returns Year + Quarter (Roman numerals) separately,
  not a combined TimePeriod field; add _period_label() helper and update sort
  keys in both bea_client.py and bea_insights.py
- Fix industry selectbox resetting on rerun: use per-client key
  bea_industry_{client_id} so each client remembers its own industry selection
- Add BEA economic context box to Master_QBR_Template.pptx with {{BEA_*}}
  placeholders on the Executive Summary slide

Co-Authored-By: Claude Sonnet 4.6 <noreply@anthropic.com>
</commit_message>
<xml_diff>
--- a/Master_QBR_Template.pptx
+++ b/Master_QBR_Template.pptx
@@ -3332,6 +3332,121 @@
             </a:pPr>
             <a:r>
               <a:t>• We managed {{TICKET_COUNT}} total IT events this quarter to keep your business running.</a:t>
+            </a:r>
+          </a:p>
+        </p:txBody>
+      </p:sp>
+      <p:sp>
+        <p:nvSpPr>
+          <p:cNvPr id="4" name="Rectangle 3"/>
+          <p:cNvSpPr/>
+          <p:nvPr/>
+        </p:nvSpPr>
+        <p:spPr>
+          <a:xfrm>
+            <a:off x="457200" y="5486400"/>
+            <a:ext cx="8229600" cy="1097280"/>
+          </a:xfrm>
+          <a:prstGeom prst="rect">
+            <a:avLst/>
+          </a:prstGeom>
+          <a:solidFill>
+            <a:srgbClr val="DBEAFE"/>
+          </a:solidFill>
+          <a:ln>
+            <a:solidFill>
+              <a:srgbClr val="2E5C8A"/>
+            </a:solidFill>
+          </a:ln>
+        </p:spPr>
+        <p:style>
+          <a:lnRef idx="1">
+            <a:schemeClr val="accent1"/>
+          </a:lnRef>
+          <a:fillRef idx="3">
+            <a:schemeClr val="accent1"/>
+          </a:fillRef>
+          <a:effectRef idx="2">
+            <a:schemeClr val="accent1"/>
+          </a:effectRef>
+          <a:fontRef idx="minor">
+            <a:schemeClr val="lt1"/>
+          </a:fontRef>
+        </p:style>
+        <p:txBody>
+          <a:bodyPr rtlCol="0" anchor="ctr"/>
+          <a:lstStyle/>
+          <a:p>
+            <a:pPr algn="ctr"/>
+          </a:p>
+        </p:txBody>
+      </p:sp>
+      <p:sp>
+        <p:nvSpPr>
+          <p:cNvPr id="5" name="TextBox 4"/>
+          <p:cNvSpPr txBox="1"/>
+          <p:nvPr/>
+        </p:nvSpPr>
+        <p:spPr>
+          <a:xfrm>
+            <a:off x="594360" y="5532120"/>
+            <a:ext cx="7955279" cy="411480"/>
+          </a:xfrm>
+          <a:prstGeom prst="rect">
+            <a:avLst/>
+          </a:prstGeom>
+          <a:noFill/>
+        </p:spPr>
+        <p:txBody>
+          <a:bodyPr wrap="square">
+            <a:spAutoFit/>
+          </a:bodyPr>
+          <a:lstStyle/>
+          <a:p>
+            <a:pPr>
+              <a:defRPr sz="1300" b="1">
+                <a:solidFill>
+                  <a:srgbClr val="2E5C8A"/>
+                </a:solidFill>
+              </a:defRPr>
+            </a:pPr>
+            <a:r>
+              <a:t>Industry Sector: {{BEA_INDUSTRY}}  |  GDP Value Added: {{BEA_LATEST_VALUE}} ({{BEA_LATEST_PERIOD}})</a:t>
+            </a:r>
+          </a:p>
+        </p:txBody>
+      </p:sp>
+      <p:sp>
+        <p:nvSpPr>
+          <p:cNvPr id="6" name="TextBox 5"/>
+          <p:cNvSpPr txBox="1"/>
+          <p:nvPr/>
+        </p:nvSpPr>
+        <p:spPr>
+          <a:xfrm>
+            <a:off x="594360" y="5989320"/>
+            <a:ext cx="7955279" cy="457200"/>
+          </a:xfrm>
+          <a:prstGeom prst="rect">
+            <a:avLst/>
+          </a:prstGeom>
+          <a:noFill/>
+        </p:spPr>
+        <p:txBody>
+          <a:bodyPr wrap="square">
+            <a:spAutoFit/>
+          </a:bodyPr>
+          <a:lstStyle/>
+          <a:p>
+            <a:pPr>
+              <a:defRPr sz="1200">
+                <a:solidFill>
+                  <a:srgbClr val="4A5568"/>
+                </a:solidFill>
+              </a:defRPr>
+            </a:pPr>
+            <a:r>
+              <a:t>QoQ Growth: {{BEA_QOQ_GROWTH}}  |  YoY Growth: {{BEA_YOY_GROWTH}}  |  {{BEA_TREND_LABEL}}</a:t>
             </a:r>
           </a:p>
         </p:txBody>

</xml_diff>

<commit_message>
Add .env pre-fill for sidebar, move AI settings to Settings page
- Load .env on startup and pre-fill HaloPSA/Anthropic/BEA sidebar
  fields so users don't need to re-enter credentials each session
- Move num_recs/sample_size sliders from sidebar to a new
  pages/settings.py Settings page; sidebar now links there
- Store slider values in session_state (num_recs, sample_size) so
  they persist across page navigations
- Pass num_recs through to generate_qbr(); add
  _remove_unused_rec_slots() to strip orphaned shapes from the PPTX
- Regenerate Master_QBR_Template.pptx with 10-slot recommendations

Co-Authored-By: Claude Sonnet 4.6 <noreply@anthropic.com>
</commit_message>
<xml_diff>
--- a/Master_QBR_Template.pptx
+++ b/Master_QBR_Template.pptx
@@ -4523,7 +4523,7 @@
         <p:spPr>
           <a:xfrm>
             <a:off x="1005840" y="1097280"/>
-            <a:ext cx="7589520" cy="365760"/>
+            <a:ext cx="7589520" cy="219456"/>
           </a:xfrm>
           <a:prstGeom prst="rect">
             <a:avLst/>
@@ -4557,8 +4557,8 @@
         </p:nvSpPr>
         <p:spPr>
           <a:xfrm>
-            <a:off x="1005840" y="1481328"/>
-            <a:ext cx="7589520" cy="457200"/>
+            <a:off x="1005840" y="1327708"/>
+            <a:ext cx="7589520" cy="274320"/>
           </a:xfrm>
           <a:prstGeom prst="rect">
             <a:avLst/>
@@ -4592,7 +4592,7 @@
         </p:nvSpPr>
         <p:spPr>
           <a:xfrm>
-            <a:off x="457200" y="2011680"/>
+            <a:off x="457200" y="1645919"/>
             <a:ext cx="365760" cy="365760"/>
           </a:xfrm>
           <a:prstGeom prst="rect">
@@ -4632,7 +4632,7 @@
         </p:nvSpPr>
         <p:spPr>
           <a:xfrm>
-            <a:off x="457200" y="2011680"/>
+            <a:off x="457200" y="1645919"/>
             <a:ext cx="365760" cy="365760"/>
           </a:xfrm>
           <a:prstGeom prst="rect">
@@ -4667,8 +4667,8 @@
         </p:nvSpPr>
         <p:spPr>
           <a:xfrm>
-            <a:off x="1005840" y="2011680"/>
-            <a:ext cx="7589520" cy="365760"/>
+            <a:off x="1005840" y="1645919"/>
+            <a:ext cx="7589520" cy="219456"/>
           </a:xfrm>
           <a:prstGeom prst="rect">
             <a:avLst/>
@@ -4702,8 +4702,8 @@
         </p:nvSpPr>
         <p:spPr>
           <a:xfrm>
-            <a:off x="1005840" y="2395728"/>
-            <a:ext cx="7589520" cy="457200"/>
+            <a:off x="1005840" y="1876348"/>
+            <a:ext cx="7589520" cy="274320"/>
           </a:xfrm>
           <a:prstGeom prst="rect">
             <a:avLst/>
@@ -4737,7 +4737,7 @@
         </p:nvSpPr>
         <p:spPr>
           <a:xfrm>
-            <a:off x="457200" y="2926080"/>
+            <a:off x="457200" y="2194560"/>
             <a:ext cx="365760" cy="365760"/>
           </a:xfrm>
           <a:prstGeom prst="rect">
@@ -4777,7 +4777,7 @@
         </p:nvSpPr>
         <p:spPr>
           <a:xfrm>
-            <a:off x="457200" y="2926080"/>
+            <a:off x="457200" y="2194560"/>
             <a:ext cx="365760" cy="365760"/>
           </a:xfrm>
           <a:prstGeom prst="rect">
@@ -4812,8 +4812,8 @@
         </p:nvSpPr>
         <p:spPr>
           <a:xfrm>
-            <a:off x="1005840" y="2926080"/>
-            <a:ext cx="7589520" cy="365760"/>
+            <a:off x="1005840" y="2194560"/>
+            <a:ext cx="7589520" cy="219456"/>
           </a:xfrm>
           <a:prstGeom prst="rect">
             <a:avLst/>
@@ -4847,8 +4847,8 @@
         </p:nvSpPr>
         <p:spPr>
           <a:xfrm>
-            <a:off x="1005840" y="3310128"/>
-            <a:ext cx="7589520" cy="457200"/>
+            <a:off x="1005840" y="2424988"/>
+            <a:ext cx="7589520" cy="274320"/>
           </a:xfrm>
           <a:prstGeom prst="rect">
             <a:avLst/>
@@ -4870,6 +4870,1021 @@
             </a:pPr>
             <a:r>
               <a:t>{{REC_3_RATIONALE}}</a:t>
+            </a:r>
+          </a:p>
+        </p:txBody>
+      </p:sp>
+      <p:sp>
+        <p:nvSpPr>
+          <p:cNvPr id="15" name="Rectangle 14"/>
+          <p:cNvSpPr/>
+          <p:nvPr/>
+        </p:nvSpPr>
+        <p:spPr>
+          <a:xfrm>
+            <a:off x="457200" y="2743200"/>
+            <a:ext cx="365760" cy="365760"/>
+          </a:xfrm>
+          <a:prstGeom prst="rect">
+            <a:avLst/>
+          </a:prstGeom>
+          <a:solidFill>
+            <a:srgbClr val="2E5C8A"/>
+          </a:solidFill>
+        </p:spPr>
+        <p:style>
+          <a:lnRef idx="1">
+            <a:schemeClr val="accent1"/>
+          </a:lnRef>
+          <a:fillRef idx="3">
+            <a:schemeClr val="accent1"/>
+          </a:fillRef>
+          <a:effectRef idx="2">
+            <a:schemeClr val="accent1"/>
+          </a:effectRef>
+          <a:fontRef idx="minor">
+            <a:schemeClr val="lt1"/>
+          </a:fontRef>
+        </p:style>
+        <p:txBody>
+          <a:bodyPr rtlCol="0" anchor="ctr"/>
+          <a:lstStyle/>
+          <a:p>
+            <a:pPr algn="ctr"/>
+          </a:p>
+        </p:txBody>
+      </p:sp>
+      <p:sp>
+        <p:nvSpPr>
+          <p:cNvPr id="16" name="TextBox 15"/>
+          <p:cNvSpPr txBox="1"/>
+          <p:nvPr/>
+        </p:nvSpPr>
+        <p:spPr>
+          <a:xfrm>
+            <a:off x="457200" y="2743200"/>
+            <a:ext cx="365760" cy="365760"/>
+          </a:xfrm>
+          <a:prstGeom prst="rect">
+            <a:avLst/>
+          </a:prstGeom>
+          <a:noFill/>
+        </p:spPr>
+        <p:txBody>
+          <a:bodyPr wrap="none">
+            <a:spAutoFit/>
+          </a:bodyPr>
+          <a:lstStyle/>
+          <a:p>
+            <a:pPr algn="ctr">
+              <a:defRPr sz="1600" b="1">
+                <a:solidFill>
+                  <a:srgbClr val="FFFFFF"/>
+                </a:solidFill>
+              </a:defRPr>
+            </a:pPr>
+            <a:r>
+              <a:t>4</a:t>
+            </a:r>
+          </a:p>
+        </p:txBody>
+      </p:sp>
+      <p:sp>
+        <p:nvSpPr>
+          <p:cNvPr id="17" name="TextBox 16"/>
+          <p:cNvSpPr txBox="1"/>
+          <p:nvPr/>
+        </p:nvSpPr>
+        <p:spPr>
+          <a:xfrm>
+            <a:off x="1005840" y="2743200"/>
+            <a:ext cx="7589520" cy="219456"/>
+          </a:xfrm>
+          <a:prstGeom prst="rect">
+            <a:avLst/>
+          </a:prstGeom>
+          <a:noFill/>
+        </p:spPr>
+        <p:txBody>
+          <a:bodyPr wrap="none">
+            <a:spAutoFit/>
+          </a:bodyPr>
+          <a:lstStyle/>
+          <a:p>
+            <a:pPr>
+              <a:defRPr sz="1400" b="1">
+                <a:solidFill>
+                  <a:srgbClr val="2E5C8A"/>
+                </a:solidFill>
+              </a:defRPr>
+            </a:pPr>
+            <a:r>
+              <a:t>{{REC_4_TITLE}}</a:t>
+            </a:r>
+          </a:p>
+        </p:txBody>
+      </p:sp>
+      <p:sp>
+        <p:nvSpPr>
+          <p:cNvPr id="18" name="TextBox 17"/>
+          <p:cNvSpPr txBox="1"/>
+          <p:nvPr/>
+        </p:nvSpPr>
+        <p:spPr>
+          <a:xfrm>
+            <a:off x="1005840" y="2973628"/>
+            <a:ext cx="7589520" cy="274320"/>
+          </a:xfrm>
+          <a:prstGeom prst="rect">
+            <a:avLst/>
+          </a:prstGeom>
+          <a:noFill/>
+        </p:spPr>
+        <p:txBody>
+          <a:bodyPr wrap="square">
+            <a:spAutoFit/>
+          </a:bodyPr>
+          <a:lstStyle/>
+          <a:p>
+            <a:pPr>
+              <a:defRPr sz="1100">
+                <a:solidFill>
+                  <a:srgbClr val="4A5568"/>
+                </a:solidFill>
+              </a:defRPr>
+            </a:pPr>
+            <a:r>
+              <a:t>{{REC_4_RATIONALE}}</a:t>
+            </a:r>
+          </a:p>
+        </p:txBody>
+      </p:sp>
+      <p:sp>
+        <p:nvSpPr>
+          <p:cNvPr id="19" name="Rectangle 18"/>
+          <p:cNvSpPr/>
+          <p:nvPr/>
+        </p:nvSpPr>
+        <p:spPr>
+          <a:xfrm>
+            <a:off x="457200" y="3291839"/>
+            <a:ext cx="365760" cy="365760"/>
+          </a:xfrm>
+          <a:prstGeom prst="rect">
+            <a:avLst/>
+          </a:prstGeom>
+          <a:solidFill>
+            <a:srgbClr val="2E5C8A"/>
+          </a:solidFill>
+        </p:spPr>
+        <p:style>
+          <a:lnRef idx="1">
+            <a:schemeClr val="accent1"/>
+          </a:lnRef>
+          <a:fillRef idx="3">
+            <a:schemeClr val="accent1"/>
+          </a:fillRef>
+          <a:effectRef idx="2">
+            <a:schemeClr val="accent1"/>
+          </a:effectRef>
+          <a:fontRef idx="minor">
+            <a:schemeClr val="lt1"/>
+          </a:fontRef>
+        </p:style>
+        <p:txBody>
+          <a:bodyPr rtlCol="0" anchor="ctr"/>
+          <a:lstStyle/>
+          <a:p>
+            <a:pPr algn="ctr"/>
+          </a:p>
+        </p:txBody>
+      </p:sp>
+      <p:sp>
+        <p:nvSpPr>
+          <p:cNvPr id="20" name="TextBox 19"/>
+          <p:cNvSpPr txBox="1"/>
+          <p:nvPr/>
+        </p:nvSpPr>
+        <p:spPr>
+          <a:xfrm>
+            <a:off x="457200" y="3291839"/>
+            <a:ext cx="365760" cy="365760"/>
+          </a:xfrm>
+          <a:prstGeom prst="rect">
+            <a:avLst/>
+          </a:prstGeom>
+          <a:noFill/>
+        </p:spPr>
+        <p:txBody>
+          <a:bodyPr wrap="none">
+            <a:spAutoFit/>
+          </a:bodyPr>
+          <a:lstStyle/>
+          <a:p>
+            <a:pPr algn="ctr">
+              <a:defRPr sz="1600" b="1">
+                <a:solidFill>
+                  <a:srgbClr val="FFFFFF"/>
+                </a:solidFill>
+              </a:defRPr>
+            </a:pPr>
+            <a:r>
+              <a:t>5</a:t>
+            </a:r>
+          </a:p>
+        </p:txBody>
+      </p:sp>
+      <p:sp>
+        <p:nvSpPr>
+          <p:cNvPr id="21" name="TextBox 20"/>
+          <p:cNvSpPr txBox="1"/>
+          <p:nvPr/>
+        </p:nvSpPr>
+        <p:spPr>
+          <a:xfrm>
+            <a:off x="1005840" y="3291839"/>
+            <a:ext cx="7589520" cy="219456"/>
+          </a:xfrm>
+          <a:prstGeom prst="rect">
+            <a:avLst/>
+          </a:prstGeom>
+          <a:noFill/>
+        </p:spPr>
+        <p:txBody>
+          <a:bodyPr wrap="none">
+            <a:spAutoFit/>
+          </a:bodyPr>
+          <a:lstStyle/>
+          <a:p>
+            <a:pPr>
+              <a:defRPr sz="1400" b="1">
+                <a:solidFill>
+                  <a:srgbClr val="2E5C8A"/>
+                </a:solidFill>
+              </a:defRPr>
+            </a:pPr>
+            <a:r>
+              <a:t>{{REC_5_TITLE}}</a:t>
+            </a:r>
+          </a:p>
+        </p:txBody>
+      </p:sp>
+      <p:sp>
+        <p:nvSpPr>
+          <p:cNvPr id="22" name="TextBox 21"/>
+          <p:cNvSpPr txBox="1"/>
+          <p:nvPr/>
+        </p:nvSpPr>
+        <p:spPr>
+          <a:xfrm>
+            <a:off x="1005840" y="3522268"/>
+            <a:ext cx="7589520" cy="274320"/>
+          </a:xfrm>
+          <a:prstGeom prst="rect">
+            <a:avLst/>
+          </a:prstGeom>
+          <a:noFill/>
+        </p:spPr>
+        <p:txBody>
+          <a:bodyPr wrap="square">
+            <a:spAutoFit/>
+          </a:bodyPr>
+          <a:lstStyle/>
+          <a:p>
+            <a:pPr>
+              <a:defRPr sz="1100">
+                <a:solidFill>
+                  <a:srgbClr val="4A5568"/>
+                </a:solidFill>
+              </a:defRPr>
+            </a:pPr>
+            <a:r>
+              <a:t>{{REC_5_RATIONALE}}</a:t>
+            </a:r>
+          </a:p>
+        </p:txBody>
+      </p:sp>
+      <p:sp>
+        <p:nvSpPr>
+          <p:cNvPr id="23" name="Rectangle 22"/>
+          <p:cNvSpPr/>
+          <p:nvPr/>
+        </p:nvSpPr>
+        <p:spPr>
+          <a:xfrm>
+            <a:off x="457200" y="3840480"/>
+            <a:ext cx="365760" cy="365760"/>
+          </a:xfrm>
+          <a:prstGeom prst="rect">
+            <a:avLst/>
+          </a:prstGeom>
+          <a:solidFill>
+            <a:srgbClr val="2E5C8A"/>
+          </a:solidFill>
+        </p:spPr>
+        <p:style>
+          <a:lnRef idx="1">
+            <a:schemeClr val="accent1"/>
+          </a:lnRef>
+          <a:fillRef idx="3">
+            <a:schemeClr val="accent1"/>
+          </a:fillRef>
+          <a:effectRef idx="2">
+            <a:schemeClr val="accent1"/>
+          </a:effectRef>
+          <a:fontRef idx="minor">
+            <a:schemeClr val="lt1"/>
+          </a:fontRef>
+        </p:style>
+        <p:txBody>
+          <a:bodyPr rtlCol="0" anchor="ctr"/>
+          <a:lstStyle/>
+          <a:p>
+            <a:pPr algn="ctr"/>
+          </a:p>
+        </p:txBody>
+      </p:sp>
+      <p:sp>
+        <p:nvSpPr>
+          <p:cNvPr id="24" name="TextBox 23"/>
+          <p:cNvSpPr txBox="1"/>
+          <p:nvPr/>
+        </p:nvSpPr>
+        <p:spPr>
+          <a:xfrm>
+            <a:off x="457200" y="3840480"/>
+            <a:ext cx="365760" cy="365760"/>
+          </a:xfrm>
+          <a:prstGeom prst="rect">
+            <a:avLst/>
+          </a:prstGeom>
+          <a:noFill/>
+        </p:spPr>
+        <p:txBody>
+          <a:bodyPr wrap="none">
+            <a:spAutoFit/>
+          </a:bodyPr>
+          <a:lstStyle/>
+          <a:p>
+            <a:pPr algn="ctr">
+              <a:defRPr sz="1600" b="1">
+                <a:solidFill>
+                  <a:srgbClr val="FFFFFF"/>
+                </a:solidFill>
+              </a:defRPr>
+            </a:pPr>
+            <a:r>
+              <a:t>6</a:t>
+            </a:r>
+          </a:p>
+        </p:txBody>
+      </p:sp>
+      <p:sp>
+        <p:nvSpPr>
+          <p:cNvPr id="25" name="TextBox 24"/>
+          <p:cNvSpPr txBox="1"/>
+          <p:nvPr/>
+        </p:nvSpPr>
+        <p:spPr>
+          <a:xfrm>
+            <a:off x="1005840" y="3840480"/>
+            <a:ext cx="7589520" cy="219456"/>
+          </a:xfrm>
+          <a:prstGeom prst="rect">
+            <a:avLst/>
+          </a:prstGeom>
+          <a:noFill/>
+        </p:spPr>
+        <p:txBody>
+          <a:bodyPr wrap="none">
+            <a:spAutoFit/>
+          </a:bodyPr>
+          <a:lstStyle/>
+          <a:p>
+            <a:pPr>
+              <a:defRPr sz="1400" b="1">
+                <a:solidFill>
+                  <a:srgbClr val="2E5C8A"/>
+                </a:solidFill>
+              </a:defRPr>
+            </a:pPr>
+            <a:r>
+              <a:t>{{REC_6_TITLE}}</a:t>
+            </a:r>
+          </a:p>
+        </p:txBody>
+      </p:sp>
+      <p:sp>
+        <p:nvSpPr>
+          <p:cNvPr id="26" name="TextBox 25"/>
+          <p:cNvSpPr txBox="1"/>
+          <p:nvPr/>
+        </p:nvSpPr>
+        <p:spPr>
+          <a:xfrm>
+            <a:off x="1005840" y="4070908"/>
+            <a:ext cx="7589520" cy="274320"/>
+          </a:xfrm>
+          <a:prstGeom prst="rect">
+            <a:avLst/>
+          </a:prstGeom>
+          <a:noFill/>
+        </p:spPr>
+        <p:txBody>
+          <a:bodyPr wrap="square">
+            <a:spAutoFit/>
+          </a:bodyPr>
+          <a:lstStyle/>
+          <a:p>
+            <a:pPr>
+              <a:defRPr sz="1100">
+                <a:solidFill>
+                  <a:srgbClr val="4A5568"/>
+                </a:solidFill>
+              </a:defRPr>
+            </a:pPr>
+            <a:r>
+              <a:t>{{REC_6_RATIONALE}}</a:t>
+            </a:r>
+          </a:p>
+        </p:txBody>
+      </p:sp>
+      <p:sp>
+        <p:nvSpPr>
+          <p:cNvPr id="27" name="Rectangle 26"/>
+          <p:cNvSpPr/>
+          <p:nvPr/>
+        </p:nvSpPr>
+        <p:spPr>
+          <a:xfrm>
+            <a:off x="457200" y="4389120"/>
+            <a:ext cx="365760" cy="365760"/>
+          </a:xfrm>
+          <a:prstGeom prst="rect">
+            <a:avLst/>
+          </a:prstGeom>
+          <a:solidFill>
+            <a:srgbClr val="2E5C8A"/>
+          </a:solidFill>
+        </p:spPr>
+        <p:style>
+          <a:lnRef idx="1">
+            <a:schemeClr val="accent1"/>
+          </a:lnRef>
+          <a:fillRef idx="3">
+            <a:schemeClr val="accent1"/>
+          </a:fillRef>
+          <a:effectRef idx="2">
+            <a:schemeClr val="accent1"/>
+          </a:effectRef>
+          <a:fontRef idx="minor">
+            <a:schemeClr val="lt1"/>
+          </a:fontRef>
+        </p:style>
+        <p:txBody>
+          <a:bodyPr rtlCol="0" anchor="ctr"/>
+          <a:lstStyle/>
+          <a:p>
+            <a:pPr algn="ctr"/>
+          </a:p>
+        </p:txBody>
+      </p:sp>
+      <p:sp>
+        <p:nvSpPr>
+          <p:cNvPr id="28" name="TextBox 27"/>
+          <p:cNvSpPr txBox="1"/>
+          <p:nvPr/>
+        </p:nvSpPr>
+        <p:spPr>
+          <a:xfrm>
+            <a:off x="457200" y="4389120"/>
+            <a:ext cx="365760" cy="365760"/>
+          </a:xfrm>
+          <a:prstGeom prst="rect">
+            <a:avLst/>
+          </a:prstGeom>
+          <a:noFill/>
+        </p:spPr>
+        <p:txBody>
+          <a:bodyPr wrap="none">
+            <a:spAutoFit/>
+          </a:bodyPr>
+          <a:lstStyle/>
+          <a:p>
+            <a:pPr algn="ctr">
+              <a:defRPr sz="1600" b="1">
+                <a:solidFill>
+                  <a:srgbClr val="FFFFFF"/>
+                </a:solidFill>
+              </a:defRPr>
+            </a:pPr>
+            <a:r>
+              <a:t>7</a:t>
+            </a:r>
+          </a:p>
+        </p:txBody>
+      </p:sp>
+      <p:sp>
+        <p:nvSpPr>
+          <p:cNvPr id="29" name="TextBox 28"/>
+          <p:cNvSpPr txBox="1"/>
+          <p:nvPr/>
+        </p:nvSpPr>
+        <p:spPr>
+          <a:xfrm>
+            <a:off x="1005840" y="4389120"/>
+            <a:ext cx="7589520" cy="219456"/>
+          </a:xfrm>
+          <a:prstGeom prst="rect">
+            <a:avLst/>
+          </a:prstGeom>
+          <a:noFill/>
+        </p:spPr>
+        <p:txBody>
+          <a:bodyPr wrap="none">
+            <a:spAutoFit/>
+          </a:bodyPr>
+          <a:lstStyle/>
+          <a:p>
+            <a:pPr>
+              <a:defRPr sz="1400" b="1">
+                <a:solidFill>
+                  <a:srgbClr val="2E5C8A"/>
+                </a:solidFill>
+              </a:defRPr>
+            </a:pPr>
+            <a:r>
+              <a:t>{{REC_7_TITLE}}</a:t>
+            </a:r>
+          </a:p>
+        </p:txBody>
+      </p:sp>
+      <p:sp>
+        <p:nvSpPr>
+          <p:cNvPr id="30" name="TextBox 29"/>
+          <p:cNvSpPr txBox="1"/>
+          <p:nvPr/>
+        </p:nvSpPr>
+        <p:spPr>
+          <a:xfrm>
+            <a:off x="1005840" y="4619548"/>
+            <a:ext cx="7589520" cy="274320"/>
+          </a:xfrm>
+          <a:prstGeom prst="rect">
+            <a:avLst/>
+          </a:prstGeom>
+          <a:noFill/>
+        </p:spPr>
+        <p:txBody>
+          <a:bodyPr wrap="square">
+            <a:spAutoFit/>
+          </a:bodyPr>
+          <a:lstStyle/>
+          <a:p>
+            <a:pPr>
+              <a:defRPr sz="1100">
+                <a:solidFill>
+                  <a:srgbClr val="4A5568"/>
+                </a:solidFill>
+              </a:defRPr>
+            </a:pPr>
+            <a:r>
+              <a:t>{{REC_7_RATIONALE}}</a:t>
+            </a:r>
+          </a:p>
+        </p:txBody>
+      </p:sp>
+      <p:sp>
+        <p:nvSpPr>
+          <p:cNvPr id="31" name="Rectangle 30"/>
+          <p:cNvSpPr/>
+          <p:nvPr/>
+        </p:nvSpPr>
+        <p:spPr>
+          <a:xfrm>
+            <a:off x="457200" y="4937760"/>
+            <a:ext cx="365760" cy="365760"/>
+          </a:xfrm>
+          <a:prstGeom prst="rect">
+            <a:avLst/>
+          </a:prstGeom>
+          <a:solidFill>
+            <a:srgbClr val="2E5C8A"/>
+          </a:solidFill>
+        </p:spPr>
+        <p:style>
+          <a:lnRef idx="1">
+            <a:schemeClr val="accent1"/>
+          </a:lnRef>
+          <a:fillRef idx="3">
+            <a:schemeClr val="accent1"/>
+          </a:fillRef>
+          <a:effectRef idx="2">
+            <a:schemeClr val="accent1"/>
+          </a:effectRef>
+          <a:fontRef idx="minor">
+            <a:schemeClr val="lt1"/>
+          </a:fontRef>
+        </p:style>
+        <p:txBody>
+          <a:bodyPr rtlCol="0" anchor="ctr"/>
+          <a:lstStyle/>
+          <a:p>
+            <a:pPr algn="ctr"/>
+          </a:p>
+        </p:txBody>
+      </p:sp>
+      <p:sp>
+        <p:nvSpPr>
+          <p:cNvPr id="32" name="TextBox 31"/>
+          <p:cNvSpPr txBox="1"/>
+          <p:nvPr/>
+        </p:nvSpPr>
+        <p:spPr>
+          <a:xfrm>
+            <a:off x="457200" y="4937760"/>
+            <a:ext cx="365760" cy="365760"/>
+          </a:xfrm>
+          <a:prstGeom prst="rect">
+            <a:avLst/>
+          </a:prstGeom>
+          <a:noFill/>
+        </p:spPr>
+        <p:txBody>
+          <a:bodyPr wrap="none">
+            <a:spAutoFit/>
+          </a:bodyPr>
+          <a:lstStyle/>
+          <a:p>
+            <a:pPr algn="ctr">
+              <a:defRPr sz="1600" b="1">
+                <a:solidFill>
+                  <a:srgbClr val="FFFFFF"/>
+                </a:solidFill>
+              </a:defRPr>
+            </a:pPr>
+            <a:r>
+              <a:t>8</a:t>
+            </a:r>
+          </a:p>
+        </p:txBody>
+      </p:sp>
+      <p:sp>
+        <p:nvSpPr>
+          <p:cNvPr id="33" name="TextBox 32"/>
+          <p:cNvSpPr txBox="1"/>
+          <p:nvPr/>
+        </p:nvSpPr>
+        <p:spPr>
+          <a:xfrm>
+            <a:off x="1005840" y="4937760"/>
+            <a:ext cx="7589520" cy="219456"/>
+          </a:xfrm>
+          <a:prstGeom prst="rect">
+            <a:avLst/>
+          </a:prstGeom>
+          <a:noFill/>
+        </p:spPr>
+        <p:txBody>
+          <a:bodyPr wrap="none">
+            <a:spAutoFit/>
+          </a:bodyPr>
+          <a:lstStyle/>
+          <a:p>
+            <a:pPr>
+              <a:defRPr sz="1400" b="1">
+                <a:solidFill>
+                  <a:srgbClr val="2E5C8A"/>
+                </a:solidFill>
+              </a:defRPr>
+            </a:pPr>
+            <a:r>
+              <a:t>{{REC_8_TITLE}}</a:t>
+            </a:r>
+          </a:p>
+        </p:txBody>
+      </p:sp>
+      <p:sp>
+        <p:nvSpPr>
+          <p:cNvPr id="34" name="TextBox 33"/>
+          <p:cNvSpPr txBox="1"/>
+          <p:nvPr/>
+        </p:nvSpPr>
+        <p:spPr>
+          <a:xfrm>
+            <a:off x="1005840" y="5168188"/>
+            <a:ext cx="7589520" cy="274320"/>
+          </a:xfrm>
+          <a:prstGeom prst="rect">
+            <a:avLst/>
+          </a:prstGeom>
+          <a:noFill/>
+        </p:spPr>
+        <p:txBody>
+          <a:bodyPr wrap="square">
+            <a:spAutoFit/>
+          </a:bodyPr>
+          <a:lstStyle/>
+          <a:p>
+            <a:pPr>
+              <a:defRPr sz="1100">
+                <a:solidFill>
+                  <a:srgbClr val="4A5568"/>
+                </a:solidFill>
+              </a:defRPr>
+            </a:pPr>
+            <a:r>
+              <a:t>{{REC_8_RATIONALE}}</a:t>
+            </a:r>
+          </a:p>
+        </p:txBody>
+      </p:sp>
+      <p:sp>
+        <p:nvSpPr>
+          <p:cNvPr id="35" name="Rectangle 34"/>
+          <p:cNvSpPr/>
+          <p:nvPr/>
+        </p:nvSpPr>
+        <p:spPr>
+          <a:xfrm>
+            <a:off x="457200" y="5486400"/>
+            <a:ext cx="365760" cy="365760"/>
+          </a:xfrm>
+          <a:prstGeom prst="rect">
+            <a:avLst/>
+          </a:prstGeom>
+          <a:solidFill>
+            <a:srgbClr val="2E5C8A"/>
+          </a:solidFill>
+        </p:spPr>
+        <p:style>
+          <a:lnRef idx="1">
+            <a:schemeClr val="accent1"/>
+          </a:lnRef>
+          <a:fillRef idx="3">
+            <a:schemeClr val="accent1"/>
+          </a:fillRef>
+          <a:effectRef idx="2">
+            <a:schemeClr val="accent1"/>
+          </a:effectRef>
+          <a:fontRef idx="minor">
+            <a:schemeClr val="lt1"/>
+          </a:fontRef>
+        </p:style>
+        <p:txBody>
+          <a:bodyPr rtlCol="0" anchor="ctr"/>
+          <a:lstStyle/>
+          <a:p>
+            <a:pPr algn="ctr"/>
+          </a:p>
+        </p:txBody>
+      </p:sp>
+      <p:sp>
+        <p:nvSpPr>
+          <p:cNvPr id="36" name="TextBox 35"/>
+          <p:cNvSpPr txBox="1"/>
+          <p:nvPr/>
+        </p:nvSpPr>
+        <p:spPr>
+          <a:xfrm>
+            <a:off x="457200" y="5486400"/>
+            <a:ext cx="365760" cy="365760"/>
+          </a:xfrm>
+          <a:prstGeom prst="rect">
+            <a:avLst/>
+          </a:prstGeom>
+          <a:noFill/>
+        </p:spPr>
+        <p:txBody>
+          <a:bodyPr wrap="none">
+            <a:spAutoFit/>
+          </a:bodyPr>
+          <a:lstStyle/>
+          <a:p>
+            <a:pPr algn="ctr">
+              <a:defRPr sz="1600" b="1">
+                <a:solidFill>
+                  <a:srgbClr val="FFFFFF"/>
+                </a:solidFill>
+              </a:defRPr>
+            </a:pPr>
+            <a:r>
+              <a:t>9</a:t>
+            </a:r>
+          </a:p>
+        </p:txBody>
+      </p:sp>
+      <p:sp>
+        <p:nvSpPr>
+          <p:cNvPr id="37" name="TextBox 36"/>
+          <p:cNvSpPr txBox="1"/>
+          <p:nvPr/>
+        </p:nvSpPr>
+        <p:spPr>
+          <a:xfrm>
+            <a:off x="1005840" y="5486400"/>
+            <a:ext cx="7589520" cy="219456"/>
+          </a:xfrm>
+          <a:prstGeom prst="rect">
+            <a:avLst/>
+          </a:prstGeom>
+          <a:noFill/>
+        </p:spPr>
+        <p:txBody>
+          <a:bodyPr wrap="none">
+            <a:spAutoFit/>
+          </a:bodyPr>
+          <a:lstStyle/>
+          <a:p>
+            <a:pPr>
+              <a:defRPr sz="1400" b="1">
+                <a:solidFill>
+                  <a:srgbClr val="2E5C8A"/>
+                </a:solidFill>
+              </a:defRPr>
+            </a:pPr>
+            <a:r>
+              <a:t>{{REC_9_TITLE}}</a:t>
+            </a:r>
+          </a:p>
+        </p:txBody>
+      </p:sp>
+      <p:sp>
+        <p:nvSpPr>
+          <p:cNvPr id="38" name="TextBox 37"/>
+          <p:cNvSpPr txBox="1"/>
+          <p:nvPr/>
+        </p:nvSpPr>
+        <p:spPr>
+          <a:xfrm>
+            <a:off x="1005840" y="5716828"/>
+            <a:ext cx="7589520" cy="274320"/>
+          </a:xfrm>
+          <a:prstGeom prst="rect">
+            <a:avLst/>
+          </a:prstGeom>
+          <a:noFill/>
+        </p:spPr>
+        <p:txBody>
+          <a:bodyPr wrap="square">
+            <a:spAutoFit/>
+          </a:bodyPr>
+          <a:lstStyle/>
+          <a:p>
+            <a:pPr>
+              <a:defRPr sz="1100">
+                <a:solidFill>
+                  <a:srgbClr val="4A5568"/>
+                </a:solidFill>
+              </a:defRPr>
+            </a:pPr>
+            <a:r>
+              <a:t>{{REC_9_RATIONALE}}</a:t>
+            </a:r>
+          </a:p>
+        </p:txBody>
+      </p:sp>
+      <p:sp>
+        <p:nvSpPr>
+          <p:cNvPr id="39" name="Rectangle 38"/>
+          <p:cNvSpPr/>
+          <p:nvPr/>
+        </p:nvSpPr>
+        <p:spPr>
+          <a:xfrm>
+            <a:off x="457200" y="6035040"/>
+            <a:ext cx="365760" cy="365760"/>
+          </a:xfrm>
+          <a:prstGeom prst="rect">
+            <a:avLst/>
+          </a:prstGeom>
+          <a:solidFill>
+            <a:srgbClr val="2E5C8A"/>
+          </a:solidFill>
+        </p:spPr>
+        <p:style>
+          <a:lnRef idx="1">
+            <a:schemeClr val="accent1"/>
+          </a:lnRef>
+          <a:fillRef idx="3">
+            <a:schemeClr val="accent1"/>
+          </a:fillRef>
+          <a:effectRef idx="2">
+            <a:schemeClr val="accent1"/>
+          </a:effectRef>
+          <a:fontRef idx="minor">
+            <a:schemeClr val="lt1"/>
+          </a:fontRef>
+        </p:style>
+        <p:txBody>
+          <a:bodyPr rtlCol="0" anchor="ctr"/>
+          <a:lstStyle/>
+          <a:p>
+            <a:pPr algn="ctr"/>
+          </a:p>
+        </p:txBody>
+      </p:sp>
+      <p:sp>
+        <p:nvSpPr>
+          <p:cNvPr id="40" name="TextBox 39"/>
+          <p:cNvSpPr txBox="1"/>
+          <p:nvPr/>
+        </p:nvSpPr>
+        <p:spPr>
+          <a:xfrm>
+            <a:off x="457200" y="6035040"/>
+            <a:ext cx="365760" cy="365760"/>
+          </a:xfrm>
+          <a:prstGeom prst="rect">
+            <a:avLst/>
+          </a:prstGeom>
+          <a:noFill/>
+        </p:spPr>
+        <p:txBody>
+          <a:bodyPr wrap="none">
+            <a:spAutoFit/>
+          </a:bodyPr>
+          <a:lstStyle/>
+          <a:p>
+            <a:pPr algn="ctr">
+              <a:defRPr sz="1600" b="1">
+                <a:solidFill>
+                  <a:srgbClr val="FFFFFF"/>
+                </a:solidFill>
+              </a:defRPr>
+            </a:pPr>
+            <a:r>
+              <a:t>10</a:t>
+            </a:r>
+          </a:p>
+        </p:txBody>
+      </p:sp>
+      <p:sp>
+        <p:nvSpPr>
+          <p:cNvPr id="41" name="TextBox 40"/>
+          <p:cNvSpPr txBox="1"/>
+          <p:nvPr/>
+        </p:nvSpPr>
+        <p:spPr>
+          <a:xfrm>
+            <a:off x="1005840" y="6035040"/>
+            <a:ext cx="7589520" cy="219456"/>
+          </a:xfrm>
+          <a:prstGeom prst="rect">
+            <a:avLst/>
+          </a:prstGeom>
+          <a:noFill/>
+        </p:spPr>
+        <p:txBody>
+          <a:bodyPr wrap="none">
+            <a:spAutoFit/>
+          </a:bodyPr>
+          <a:lstStyle/>
+          <a:p>
+            <a:pPr>
+              <a:defRPr sz="1400" b="1">
+                <a:solidFill>
+                  <a:srgbClr val="2E5C8A"/>
+                </a:solidFill>
+              </a:defRPr>
+            </a:pPr>
+            <a:r>
+              <a:t>{{REC_10_TITLE}}</a:t>
+            </a:r>
+          </a:p>
+        </p:txBody>
+      </p:sp>
+      <p:sp>
+        <p:nvSpPr>
+          <p:cNvPr id="42" name="TextBox 41"/>
+          <p:cNvSpPr txBox="1"/>
+          <p:nvPr/>
+        </p:nvSpPr>
+        <p:spPr>
+          <a:xfrm>
+            <a:off x="1005840" y="6265468"/>
+            <a:ext cx="7589520" cy="274320"/>
+          </a:xfrm>
+          <a:prstGeom prst="rect">
+            <a:avLst/>
+          </a:prstGeom>
+          <a:noFill/>
+        </p:spPr>
+        <p:txBody>
+          <a:bodyPr wrap="square">
+            <a:spAutoFit/>
+          </a:bodyPr>
+          <a:lstStyle/>
+          <a:p>
+            <a:pPr>
+              <a:defRPr sz="1100">
+                <a:solidFill>
+                  <a:srgbClr val="4A5568"/>
+                </a:solidFill>
+              </a:defRPr>
+            </a:pPr>
+            <a:r>
+              <a:t>{{REC_10_RATIONALE}}</a:t>
             </a:r>
           </a:p>
         </p:txBody>

</xml_diff>

<commit_message>
Implement AI recommendation feature with settings dialog, branding, and health score
- Move settings (HaloPSA credentials, AI toggles, BEA API key) from sidebar into
  a @st.dialog opened via a gear icon in the page header; hide sidebar via CSS
- Add Streamlit brand theme (.streamlit/config.toml): indigo primary (#242E65),
  orange accent (#F05523), white background, sans-serif font
- Add Client Health Score: computed from 4 KPIs (0–100), badge shown in results
  dashboard with Excellent/Needs Attention/At Risk thresholds
- Add dynamic recommendation slots: Master_QBR_Template.pptx holds all 10 slots;
  unused slots are removed at runtime by _remove_unused_rec_slots()
- Clarify ticket sampling status message when AI is enabled and count > sample_size
- Remove pages/settings.py (settings consolidated into dialog in app.py)
- Update Master_QBR_Template.pptx and create_qbr_template.py for new slide layout

Co-Authored-By: Claude Sonnet 4.6 <noreply@anthropic.com>
</commit_message>
<xml_diff>
--- a/Master_QBR_Template.pptx
+++ b/Master_QBR_Template.pptx
@@ -3120,7 +3120,7 @@
             <a:pPr algn="ctr">
               <a:defRPr sz="4800" b="1">
                 <a:solidFill>
-                  <a:srgbClr val="2E5C8A"/>
+                  <a:srgbClr val="242E65"/>
                 </a:solidFill>
               </a:defRPr>
             </a:pPr>
@@ -3243,7 +3243,7 @@
             <a:pPr>
               <a:defRPr sz="4000" b="1">
                 <a:solidFill>
-                  <a:srgbClr val="2E5C8A"/>
+                  <a:srgbClr val="242E65"/>
                 </a:solidFill>
               </a:defRPr>
             </a:pPr>
@@ -3355,7 +3355,7 @@
           </a:solidFill>
           <a:ln>
             <a:solidFill>
-              <a:srgbClr val="2E5C8A"/>
+              <a:srgbClr val="242E65"/>
             </a:solidFill>
           </a:ln>
         </p:spPr>
@@ -3406,7 +3406,7 @@
             <a:pPr>
               <a:defRPr sz="1300" b="1">
                 <a:solidFill>
-                  <a:srgbClr val="2E5C8A"/>
+                  <a:srgbClr val="242E65"/>
                 </a:solidFill>
               </a:defRPr>
             </a:pPr>
@@ -3494,7 +3494,7 @@
             <a:pPr>
               <a:defRPr sz="4000" b="1">
                 <a:solidFill>
-                  <a:srgbClr val="2E5C8A"/>
+                  <a:srgbClr val="242E65"/>
                 </a:solidFill>
               </a:defRPr>
             </a:pPr>
@@ -3523,7 +3523,7 @@
           </a:solidFill>
           <a:ln>
             <a:solidFill>
-              <a:srgbClr val="2E5C8A"/>
+              <a:srgbClr val="242E65"/>
             </a:solidFill>
           </a:ln>
         </p:spPr>
@@ -3609,7 +3609,7 @@
             <a:pPr algn="ctr">
               <a:defRPr sz="2600" b="1">
                 <a:solidFill>
-                  <a:srgbClr val="2E5C8A"/>
+                  <a:srgbClr val="242E65"/>
                 </a:solidFill>
               </a:defRPr>
             </a:pPr>
@@ -3638,7 +3638,7 @@
           </a:solidFill>
           <a:ln>
             <a:solidFill>
-              <a:srgbClr val="2E5C8A"/>
+              <a:srgbClr val="242E65"/>
             </a:solidFill>
           </a:ln>
         </p:spPr>
@@ -3724,7 +3724,7 @@
             <a:pPr algn="ctr">
               <a:defRPr sz="2600" b="1">
                 <a:solidFill>
-                  <a:srgbClr val="2E5C8A"/>
+                  <a:srgbClr val="242E65"/>
                 </a:solidFill>
               </a:defRPr>
             </a:pPr>
@@ -3753,7 +3753,7 @@
           </a:solidFill>
           <a:ln>
             <a:solidFill>
-              <a:srgbClr val="2E5C8A"/>
+              <a:srgbClr val="242E65"/>
             </a:solidFill>
           </a:ln>
         </p:spPr>
@@ -3839,7 +3839,7 @@
             <a:pPr algn="ctr">
               <a:defRPr sz="2600" b="1">
                 <a:solidFill>
-                  <a:srgbClr val="2E5C8A"/>
+                  <a:srgbClr val="242E65"/>
                 </a:solidFill>
               </a:defRPr>
             </a:pPr>
@@ -3892,7 +3892,7 @@
             <a:pPr>
               <a:defRPr sz="4000" b="1">
                 <a:solidFill>
-                  <a:srgbClr val="2E5C8A"/>
+                  <a:srgbClr val="242E65"/>
                 </a:solidFill>
               </a:defRPr>
             </a:pPr>
@@ -4060,7 +4060,7 @@
             <a:pPr>
               <a:defRPr sz="3600" b="1">
                 <a:solidFill>
-                  <a:srgbClr val="2E5C8A"/>
+                  <a:srgbClr val="242E65"/>
                 </a:solidFill>
               </a:defRPr>
             </a:pPr>
@@ -4308,7 +4308,7 @@
             <a:pPr>
               <a:defRPr sz="3600" b="1">
                 <a:solidFill>
-                  <a:srgbClr val="2E5C8A"/>
+                  <a:srgbClr val="242E65"/>
                 </a:solidFill>
               </a:defRPr>
             </a:pPr>
@@ -4429,7 +4429,7 @@
             <a:pPr>
               <a:defRPr sz="3600" b="1">
                 <a:solidFill>
-                  <a:srgbClr val="2E5C8A"/>
+                  <a:srgbClr val="242E65"/>
                 </a:solidFill>
               </a:defRPr>
             </a:pPr>
@@ -4454,7 +4454,7 @@
             <a:avLst/>
           </a:prstGeom>
           <a:solidFill>
-            <a:srgbClr val="2E5C8A"/>
+            <a:srgbClr val="242E65"/>
           </a:solidFill>
         </p:spPr>
         <p:style>
@@ -4539,7 +4539,7 @@
             <a:pPr>
               <a:defRPr sz="1400" b="1">
                 <a:solidFill>
-                  <a:srgbClr val="2E5C8A"/>
+                  <a:srgbClr val="242E65"/>
                 </a:solidFill>
               </a:defRPr>
             </a:pPr>
@@ -4599,7 +4599,7 @@
             <a:avLst/>
           </a:prstGeom>
           <a:solidFill>
-            <a:srgbClr val="2E5C8A"/>
+            <a:srgbClr val="242E65"/>
           </a:solidFill>
         </p:spPr>
         <p:style>
@@ -4684,7 +4684,7 @@
             <a:pPr>
               <a:defRPr sz="1400" b="1">
                 <a:solidFill>
-                  <a:srgbClr val="2E5C8A"/>
+                  <a:srgbClr val="242E65"/>
                 </a:solidFill>
               </a:defRPr>
             </a:pPr>
@@ -4744,7 +4744,7 @@
             <a:avLst/>
           </a:prstGeom>
           <a:solidFill>
-            <a:srgbClr val="2E5C8A"/>
+            <a:srgbClr val="242E65"/>
           </a:solidFill>
         </p:spPr>
         <p:style>
@@ -4829,7 +4829,7 @@
             <a:pPr>
               <a:defRPr sz="1400" b="1">
                 <a:solidFill>
-                  <a:srgbClr val="2E5C8A"/>
+                  <a:srgbClr val="242E65"/>
                 </a:solidFill>
               </a:defRPr>
             </a:pPr>
@@ -4889,7 +4889,7 @@
             <a:avLst/>
           </a:prstGeom>
           <a:solidFill>
-            <a:srgbClr val="2E5C8A"/>
+            <a:srgbClr val="242E65"/>
           </a:solidFill>
         </p:spPr>
         <p:style>
@@ -4974,7 +4974,7 @@
             <a:pPr>
               <a:defRPr sz="1400" b="1">
                 <a:solidFill>
-                  <a:srgbClr val="2E5C8A"/>
+                  <a:srgbClr val="242E65"/>
                 </a:solidFill>
               </a:defRPr>
             </a:pPr>
@@ -5034,7 +5034,7 @@
             <a:avLst/>
           </a:prstGeom>
           <a:solidFill>
-            <a:srgbClr val="2E5C8A"/>
+            <a:srgbClr val="242E65"/>
           </a:solidFill>
         </p:spPr>
         <p:style>
@@ -5119,7 +5119,7 @@
             <a:pPr>
               <a:defRPr sz="1400" b="1">
                 <a:solidFill>
-                  <a:srgbClr val="2E5C8A"/>
+                  <a:srgbClr val="242E65"/>
                 </a:solidFill>
               </a:defRPr>
             </a:pPr>
@@ -5179,7 +5179,7 @@
             <a:avLst/>
           </a:prstGeom>
           <a:solidFill>
-            <a:srgbClr val="2E5C8A"/>
+            <a:srgbClr val="242E65"/>
           </a:solidFill>
         </p:spPr>
         <p:style>
@@ -5264,7 +5264,7 @@
             <a:pPr>
               <a:defRPr sz="1400" b="1">
                 <a:solidFill>
-                  <a:srgbClr val="2E5C8A"/>
+                  <a:srgbClr val="242E65"/>
                 </a:solidFill>
               </a:defRPr>
             </a:pPr>
@@ -5324,7 +5324,7 @@
             <a:avLst/>
           </a:prstGeom>
           <a:solidFill>
-            <a:srgbClr val="2E5C8A"/>
+            <a:srgbClr val="242E65"/>
           </a:solidFill>
         </p:spPr>
         <p:style>
@@ -5409,7 +5409,7 @@
             <a:pPr>
               <a:defRPr sz="1400" b="1">
                 <a:solidFill>
-                  <a:srgbClr val="2E5C8A"/>
+                  <a:srgbClr val="242E65"/>
                 </a:solidFill>
               </a:defRPr>
             </a:pPr>
@@ -5469,7 +5469,7 @@
             <a:avLst/>
           </a:prstGeom>
           <a:solidFill>
-            <a:srgbClr val="2E5C8A"/>
+            <a:srgbClr val="242E65"/>
           </a:solidFill>
         </p:spPr>
         <p:style>
@@ -5554,7 +5554,7 @@
             <a:pPr>
               <a:defRPr sz="1400" b="1">
                 <a:solidFill>
-                  <a:srgbClr val="2E5C8A"/>
+                  <a:srgbClr val="242E65"/>
                 </a:solidFill>
               </a:defRPr>
             </a:pPr>
@@ -5614,7 +5614,7 @@
             <a:avLst/>
           </a:prstGeom>
           <a:solidFill>
-            <a:srgbClr val="2E5C8A"/>
+            <a:srgbClr val="242E65"/>
           </a:solidFill>
         </p:spPr>
         <p:style>
@@ -5699,7 +5699,7 @@
             <a:pPr>
               <a:defRPr sz="1400" b="1">
                 <a:solidFill>
-                  <a:srgbClr val="2E5C8A"/>
+                  <a:srgbClr val="242E65"/>
                 </a:solidFill>
               </a:defRPr>
             </a:pPr>
@@ -5759,7 +5759,7 @@
             <a:avLst/>
           </a:prstGeom>
           <a:solidFill>
-            <a:srgbClr val="2E5C8A"/>
+            <a:srgbClr val="242E65"/>
           </a:solidFill>
         </p:spPr>
         <p:style>
@@ -5844,7 +5844,7 @@
             <a:pPr>
               <a:defRPr sz="1400" b="1">
                 <a:solidFill>
-                  <a:srgbClr val="2E5C8A"/>
+                  <a:srgbClr val="242E65"/>
                 </a:solidFill>
               </a:defRPr>
             </a:pPr>
@@ -5932,7 +5932,7 @@
             <a:pPr algn="ctr">
               <a:defRPr sz="4800" b="1">
                 <a:solidFill>
-                  <a:srgbClr val="2E5C8A"/>
+                  <a:srgbClr val="242E65"/>
                 </a:solidFill>
               </a:defRPr>
             </a:pPr>

</xml_diff>

<commit_message>
Implement AI recommendation feature with settings dialog, branding, and health score (#5)
- Move settings (HaloPSA credentials, AI toggles, BEA API key) from sidebar into
  a @st.dialog opened via a gear icon in the page header; hide sidebar via CSS
- Add Streamlit brand theme (.streamlit/config.toml): indigo primary (#242E65),
  orange accent (#F05523), white background, sans-serif font
- Add Client Health Score: computed from 4 KPIs (0–100), badge shown in results
  dashboard with Excellent/Needs Attention/At Risk thresholds
- Add dynamic recommendation slots: Master_QBR_Template.pptx holds all 10 slots;
  unused slots are removed at runtime by _remove_unused_rec_slots()
- Clarify ticket sampling status message when AI is enabled and count > sample_size
- Remove pages/settings.py (settings consolidated into dialog in app.py)
- Update Master_QBR_Template.pptx and create_qbr_template.py for new slide layout

Co-authored-by: Claude Sonnet 4.6 <noreply@anthropic.com>
</commit_message>
<xml_diff>
--- a/Master_QBR_Template.pptx
+++ b/Master_QBR_Template.pptx
@@ -3120,7 +3120,7 @@
             <a:pPr algn="ctr">
               <a:defRPr sz="4800" b="1">
                 <a:solidFill>
-                  <a:srgbClr val="2E5C8A"/>
+                  <a:srgbClr val="242E65"/>
                 </a:solidFill>
               </a:defRPr>
             </a:pPr>
@@ -3243,7 +3243,7 @@
             <a:pPr>
               <a:defRPr sz="4000" b="1">
                 <a:solidFill>
-                  <a:srgbClr val="2E5C8A"/>
+                  <a:srgbClr val="242E65"/>
                 </a:solidFill>
               </a:defRPr>
             </a:pPr>
@@ -3355,7 +3355,7 @@
           </a:solidFill>
           <a:ln>
             <a:solidFill>
-              <a:srgbClr val="2E5C8A"/>
+              <a:srgbClr val="242E65"/>
             </a:solidFill>
           </a:ln>
         </p:spPr>
@@ -3406,7 +3406,7 @@
             <a:pPr>
               <a:defRPr sz="1300" b="1">
                 <a:solidFill>
-                  <a:srgbClr val="2E5C8A"/>
+                  <a:srgbClr val="242E65"/>
                 </a:solidFill>
               </a:defRPr>
             </a:pPr>
@@ -3494,7 +3494,7 @@
             <a:pPr>
               <a:defRPr sz="4000" b="1">
                 <a:solidFill>
-                  <a:srgbClr val="2E5C8A"/>
+                  <a:srgbClr val="242E65"/>
                 </a:solidFill>
               </a:defRPr>
             </a:pPr>
@@ -3523,7 +3523,7 @@
           </a:solidFill>
           <a:ln>
             <a:solidFill>
-              <a:srgbClr val="2E5C8A"/>
+              <a:srgbClr val="242E65"/>
             </a:solidFill>
           </a:ln>
         </p:spPr>
@@ -3609,7 +3609,7 @@
             <a:pPr algn="ctr">
               <a:defRPr sz="2600" b="1">
                 <a:solidFill>
-                  <a:srgbClr val="2E5C8A"/>
+                  <a:srgbClr val="242E65"/>
                 </a:solidFill>
               </a:defRPr>
             </a:pPr>
@@ -3638,7 +3638,7 @@
           </a:solidFill>
           <a:ln>
             <a:solidFill>
-              <a:srgbClr val="2E5C8A"/>
+              <a:srgbClr val="242E65"/>
             </a:solidFill>
           </a:ln>
         </p:spPr>
@@ -3724,7 +3724,7 @@
             <a:pPr algn="ctr">
               <a:defRPr sz="2600" b="1">
                 <a:solidFill>
-                  <a:srgbClr val="2E5C8A"/>
+                  <a:srgbClr val="242E65"/>
                 </a:solidFill>
               </a:defRPr>
             </a:pPr>
@@ -3753,7 +3753,7 @@
           </a:solidFill>
           <a:ln>
             <a:solidFill>
-              <a:srgbClr val="2E5C8A"/>
+              <a:srgbClr val="242E65"/>
             </a:solidFill>
           </a:ln>
         </p:spPr>
@@ -3839,7 +3839,7 @@
             <a:pPr algn="ctr">
               <a:defRPr sz="2600" b="1">
                 <a:solidFill>
-                  <a:srgbClr val="2E5C8A"/>
+                  <a:srgbClr val="242E65"/>
                 </a:solidFill>
               </a:defRPr>
             </a:pPr>
@@ -3892,7 +3892,7 @@
             <a:pPr>
               <a:defRPr sz="4000" b="1">
                 <a:solidFill>
-                  <a:srgbClr val="2E5C8A"/>
+                  <a:srgbClr val="242E65"/>
                 </a:solidFill>
               </a:defRPr>
             </a:pPr>
@@ -4060,7 +4060,7 @@
             <a:pPr>
               <a:defRPr sz="3600" b="1">
                 <a:solidFill>
-                  <a:srgbClr val="2E5C8A"/>
+                  <a:srgbClr val="242E65"/>
                 </a:solidFill>
               </a:defRPr>
             </a:pPr>
@@ -4308,7 +4308,7 @@
             <a:pPr>
               <a:defRPr sz="3600" b="1">
                 <a:solidFill>
-                  <a:srgbClr val="2E5C8A"/>
+                  <a:srgbClr val="242E65"/>
                 </a:solidFill>
               </a:defRPr>
             </a:pPr>
@@ -4429,7 +4429,7 @@
             <a:pPr>
               <a:defRPr sz="3600" b="1">
                 <a:solidFill>
-                  <a:srgbClr val="2E5C8A"/>
+                  <a:srgbClr val="242E65"/>
                 </a:solidFill>
               </a:defRPr>
             </a:pPr>
@@ -4454,7 +4454,7 @@
             <a:avLst/>
           </a:prstGeom>
           <a:solidFill>
-            <a:srgbClr val="2E5C8A"/>
+            <a:srgbClr val="242E65"/>
           </a:solidFill>
         </p:spPr>
         <p:style>
@@ -4539,7 +4539,7 @@
             <a:pPr>
               <a:defRPr sz="1400" b="1">
                 <a:solidFill>
-                  <a:srgbClr val="2E5C8A"/>
+                  <a:srgbClr val="242E65"/>
                 </a:solidFill>
               </a:defRPr>
             </a:pPr>
@@ -4599,7 +4599,7 @@
             <a:avLst/>
           </a:prstGeom>
           <a:solidFill>
-            <a:srgbClr val="2E5C8A"/>
+            <a:srgbClr val="242E65"/>
           </a:solidFill>
         </p:spPr>
         <p:style>
@@ -4684,7 +4684,7 @@
             <a:pPr>
               <a:defRPr sz="1400" b="1">
                 <a:solidFill>
-                  <a:srgbClr val="2E5C8A"/>
+                  <a:srgbClr val="242E65"/>
                 </a:solidFill>
               </a:defRPr>
             </a:pPr>
@@ -4744,7 +4744,7 @@
             <a:avLst/>
           </a:prstGeom>
           <a:solidFill>
-            <a:srgbClr val="2E5C8A"/>
+            <a:srgbClr val="242E65"/>
           </a:solidFill>
         </p:spPr>
         <p:style>
@@ -4829,7 +4829,7 @@
             <a:pPr>
               <a:defRPr sz="1400" b="1">
                 <a:solidFill>
-                  <a:srgbClr val="2E5C8A"/>
+                  <a:srgbClr val="242E65"/>
                 </a:solidFill>
               </a:defRPr>
             </a:pPr>
@@ -4889,7 +4889,7 @@
             <a:avLst/>
           </a:prstGeom>
           <a:solidFill>
-            <a:srgbClr val="2E5C8A"/>
+            <a:srgbClr val="242E65"/>
           </a:solidFill>
         </p:spPr>
         <p:style>
@@ -4974,7 +4974,7 @@
             <a:pPr>
               <a:defRPr sz="1400" b="1">
                 <a:solidFill>
-                  <a:srgbClr val="2E5C8A"/>
+                  <a:srgbClr val="242E65"/>
                 </a:solidFill>
               </a:defRPr>
             </a:pPr>
@@ -5034,7 +5034,7 @@
             <a:avLst/>
           </a:prstGeom>
           <a:solidFill>
-            <a:srgbClr val="2E5C8A"/>
+            <a:srgbClr val="242E65"/>
           </a:solidFill>
         </p:spPr>
         <p:style>
@@ -5119,7 +5119,7 @@
             <a:pPr>
               <a:defRPr sz="1400" b="1">
                 <a:solidFill>
-                  <a:srgbClr val="2E5C8A"/>
+                  <a:srgbClr val="242E65"/>
                 </a:solidFill>
               </a:defRPr>
             </a:pPr>
@@ -5179,7 +5179,7 @@
             <a:avLst/>
           </a:prstGeom>
           <a:solidFill>
-            <a:srgbClr val="2E5C8A"/>
+            <a:srgbClr val="242E65"/>
           </a:solidFill>
         </p:spPr>
         <p:style>
@@ -5264,7 +5264,7 @@
             <a:pPr>
               <a:defRPr sz="1400" b="1">
                 <a:solidFill>
-                  <a:srgbClr val="2E5C8A"/>
+                  <a:srgbClr val="242E65"/>
                 </a:solidFill>
               </a:defRPr>
             </a:pPr>
@@ -5324,7 +5324,7 @@
             <a:avLst/>
           </a:prstGeom>
           <a:solidFill>
-            <a:srgbClr val="2E5C8A"/>
+            <a:srgbClr val="242E65"/>
           </a:solidFill>
         </p:spPr>
         <p:style>
@@ -5409,7 +5409,7 @@
             <a:pPr>
               <a:defRPr sz="1400" b="1">
                 <a:solidFill>
-                  <a:srgbClr val="2E5C8A"/>
+                  <a:srgbClr val="242E65"/>
                 </a:solidFill>
               </a:defRPr>
             </a:pPr>
@@ -5469,7 +5469,7 @@
             <a:avLst/>
           </a:prstGeom>
           <a:solidFill>
-            <a:srgbClr val="2E5C8A"/>
+            <a:srgbClr val="242E65"/>
           </a:solidFill>
         </p:spPr>
         <p:style>
@@ -5554,7 +5554,7 @@
             <a:pPr>
               <a:defRPr sz="1400" b="1">
                 <a:solidFill>
-                  <a:srgbClr val="2E5C8A"/>
+                  <a:srgbClr val="242E65"/>
                 </a:solidFill>
               </a:defRPr>
             </a:pPr>
@@ -5614,7 +5614,7 @@
             <a:avLst/>
           </a:prstGeom>
           <a:solidFill>
-            <a:srgbClr val="2E5C8A"/>
+            <a:srgbClr val="242E65"/>
           </a:solidFill>
         </p:spPr>
         <p:style>
@@ -5699,7 +5699,7 @@
             <a:pPr>
               <a:defRPr sz="1400" b="1">
                 <a:solidFill>
-                  <a:srgbClr val="2E5C8A"/>
+                  <a:srgbClr val="242E65"/>
                 </a:solidFill>
               </a:defRPr>
             </a:pPr>
@@ -5759,7 +5759,7 @@
             <a:avLst/>
           </a:prstGeom>
           <a:solidFill>
-            <a:srgbClr val="2E5C8A"/>
+            <a:srgbClr val="242E65"/>
           </a:solidFill>
         </p:spPr>
         <p:style>
@@ -5844,7 +5844,7 @@
             <a:pPr>
               <a:defRPr sz="1400" b="1">
                 <a:solidFill>
-                  <a:srgbClr val="2E5C8A"/>
+                  <a:srgbClr val="242E65"/>
                 </a:solidFill>
               </a:defRPr>
             </a:pPr>
@@ -5932,7 +5932,7 @@
             <a:pPr algn="ctr">
               <a:defRPr sz="4800" b="1">
                 <a:solidFill>
-                  <a:srgbClr val="2E5C8A"/>
+                  <a:srgbClr val="242E65"/>
                 </a:solidFill>
               </a:defRPr>
             </a:pPr>

</xml_diff>

<commit_message>
Fix recommendation slot overlap with runtime repositioning
- Name rec slot shapes (circle, num, title, rationale) in create_qbr_template.py
  so they are addressable by slot index at runtime
- Add _estimate_text_height_in() to generate_client_qbr.py for
  conservative text height estimation from char count and font size
- Add _reposition_rec_slots() that reads actual post-replacement text
  and stacks slots cleanly without overlap (Y_START=2.2", GAP_INNER=0.05",
  GAP_SLOT=0.2" between slots)
- Call _reposition_rec_slots() after text replacement in generate_qbr()
- Regenerate Master_QBR_Template.pptx with named shapes

Co-Authored-By: Claude Sonnet 4.6 <noreply@anthropic.com>
</commit_message>
<xml_diff>
--- a/Master_QBR_Template.pptx
+++ b/Master_QBR_Template.pptx
@@ -3261,8 +3261,8 @@
         </p:nvSpPr>
         <p:spPr>
           <a:xfrm>
-            <a:off x="914400" y="1828800"/>
-            <a:ext cx="7315200" cy="3657600"/>
+            <a:off x="914400" y="1371600"/>
+            <a:ext cx="7315200" cy="3200400"/>
           </a:xfrm>
           <a:prstGeom prst="rect">
             <a:avLst/>
@@ -3344,7 +3344,7 @@
         </p:nvSpPr>
         <p:spPr>
           <a:xfrm>
-            <a:off x="457200" y="4572000"/>
+            <a:off x="457200" y="4709160"/>
             <a:ext cx="8229600" cy="365760"/>
           </a:xfrm>
           <a:prstGeom prst="rect">
@@ -3379,7 +3379,7 @@
         </p:nvSpPr>
         <p:spPr>
           <a:xfrm>
-            <a:off x="457200" y="5120640"/>
+            <a:off x="457200" y="5166360"/>
             <a:ext cx="8229600" cy="457200"/>
           </a:xfrm>
           <a:prstGeom prst="rect">
@@ -3414,7 +3414,7 @@
         </p:nvSpPr>
         <p:spPr>
           <a:xfrm>
-            <a:off x="457200" y="5852160"/>
+            <a:off x="457200" y="5760720"/>
             <a:ext cx="8229600" cy="1097280"/>
           </a:xfrm>
           <a:prstGeom prst="rect">
@@ -3459,7 +3459,7 @@
         </p:nvSpPr>
         <p:spPr>
           <a:xfrm>
-            <a:off x="594360" y="5897880"/>
+            <a:off x="594360" y="5806440"/>
             <a:ext cx="7955279" cy="411480"/>
           </a:xfrm>
           <a:prstGeom prst="rect">
@@ -3494,7 +3494,7 @@
         </p:nvSpPr>
         <p:spPr>
           <a:xfrm>
-            <a:off x="594360" y="6355080"/>
+            <a:off x="594360" y="6263640"/>
             <a:ext cx="7955279" cy="457200"/>
           </a:xfrm>
           <a:prstGeom prst="rect">
@@ -4009,59 +4009,14 @@
       </p:sp>
       <p:sp>
         <p:nvSpPr>
-          <p:cNvPr id="4" name="Rectangle 3"/>
-          <p:cNvSpPr/>
-          <p:nvPr/>
-        </p:nvSpPr>
-        <p:spPr>
-          <a:xfrm>
-            <a:off x="1828800" y="2286000"/>
-            <a:ext cx="5486400" cy="3657600"/>
-          </a:xfrm>
-          <a:prstGeom prst="rect">
-            <a:avLst/>
-          </a:prstGeom>
-          <a:solidFill>
-            <a:srgbClr val="F0F0F0"/>
-          </a:solidFill>
-          <a:ln>
-            <a:solidFill>
-              <a:srgbClr val="4A5568"/>
-            </a:solidFill>
-          </a:ln>
-        </p:spPr>
-        <p:style>
-          <a:lnRef idx="1">
-            <a:schemeClr val="accent1"/>
-          </a:lnRef>
-          <a:fillRef idx="3">
-            <a:schemeClr val="accent1"/>
-          </a:fillRef>
-          <a:effectRef idx="2">
-            <a:schemeClr val="accent1"/>
-          </a:effectRef>
-          <a:fontRef idx="minor">
-            <a:schemeClr val="lt1"/>
-          </a:fontRef>
-        </p:style>
-        <p:txBody>
-          <a:bodyPr rtlCol="0" anchor="ctr"/>
-          <a:lstStyle/>
-          <a:p>
-            <a:pPr algn="ctr"/>
-          </a:p>
-        </p:txBody>
-      </p:sp>
-      <p:sp>
-        <p:nvSpPr>
-          <p:cNvPr id="5" name="TextBox 4"/>
+          <p:cNvPr id="4" name="TextBox 3"/>
           <p:cNvSpPr txBox="1"/>
           <p:nvPr/>
         </p:nvSpPr>
         <p:spPr>
           <a:xfrm>
-            <a:off x="1828800" y="3657600"/>
-            <a:ext cx="5486400" cy="914400"/>
+            <a:off x="457200" y="1828800"/>
+            <a:ext cx="8229600" cy="914400"/>
           </a:xfrm>
           <a:prstGeom prst="rect">
             <a:avLst/>
@@ -4605,7 +4560,7 @@
       </p:sp>
       <p:sp>
         <p:nvSpPr>
-          <p:cNvPr id="5" name="Rectangle 4"/>
+          <p:cNvPr id="5" name="rec_1_circle"/>
           <p:cNvSpPr/>
           <p:nvPr/>
         </p:nvSpPr>
@@ -4645,7 +4600,7 @@
       </p:sp>
       <p:sp>
         <p:nvSpPr>
-          <p:cNvPr id="6" name="TextBox 5"/>
+          <p:cNvPr id="6" name="rec_1_num"/>
           <p:cNvSpPr txBox="1"/>
           <p:nvPr/>
         </p:nvSpPr>
@@ -4680,7 +4635,7 @@
       </p:sp>
       <p:sp>
         <p:nvSpPr>
-          <p:cNvPr id="7" name="TextBox 6"/>
+          <p:cNvPr id="7" name="rec_1_title"/>
           <p:cNvSpPr txBox="1"/>
           <p:nvPr/>
         </p:nvSpPr>
@@ -4715,7 +4670,7 @@
       </p:sp>
       <p:sp>
         <p:nvSpPr>
-          <p:cNvPr id="8" name="TextBox 7"/>
+          <p:cNvPr id="8" name="rec_1_rationale"/>
           <p:cNvSpPr txBox="1"/>
           <p:nvPr/>
         </p:nvSpPr>
@@ -4750,7 +4705,7 @@
       </p:sp>
       <p:sp>
         <p:nvSpPr>
-          <p:cNvPr id="9" name="Rectangle 8"/>
+          <p:cNvPr id="9" name="rec_2_circle"/>
           <p:cNvSpPr/>
           <p:nvPr/>
         </p:nvSpPr>
@@ -4790,7 +4745,7 @@
       </p:sp>
       <p:sp>
         <p:nvSpPr>
-          <p:cNvPr id="10" name="TextBox 9"/>
+          <p:cNvPr id="10" name="rec_2_num"/>
           <p:cNvSpPr txBox="1"/>
           <p:nvPr/>
         </p:nvSpPr>
@@ -4825,7 +4780,7 @@
       </p:sp>
       <p:sp>
         <p:nvSpPr>
-          <p:cNvPr id="11" name="TextBox 10"/>
+          <p:cNvPr id="11" name="rec_2_title"/>
           <p:cNvSpPr txBox="1"/>
           <p:nvPr/>
         </p:nvSpPr>
@@ -4860,7 +4815,7 @@
       </p:sp>
       <p:sp>
         <p:nvSpPr>
-          <p:cNvPr id="12" name="TextBox 11"/>
+          <p:cNvPr id="12" name="rec_2_rationale"/>
           <p:cNvSpPr txBox="1"/>
           <p:nvPr/>
         </p:nvSpPr>
@@ -4895,7 +4850,7 @@
       </p:sp>
       <p:sp>
         <p:nvSpPr>
-          <p:cNvPr id="13" name="Rectangle 12"/>
+          <p:cNvPr id="13" name="rec_3_circle"/>
           <p:cNvSpPr/>
           <p:nvPr/>
         </p:nvSpPr>
@@ -4935,7 +4890,7 @@
       </p:sp>
       <p:sp>
         <p:nvSpPr>
-          <p:cNvPr id="14" name="TextBox 13"/>
+          <p:cNvPr id="14" name="rec_3_num"/>
           <p:cNvSpPr txBox="1"/>
           <p:nvPr/>
         </p:nvSpPr>
@@ -4970,7 +4925,7 @@
       </p:sp>
       <p:sp>
         <p:nvSpPr>
-          <p:cNvPr id="15" name="TextBox 14"/>
+          <p:cNvPr id="15" name="rec_3_title"/>
           <p:cNvSpPr txBox="1"/>
           <p:nvPr/>
         </p:nvSpPr>
@@ -5005,7 +4960,7 @@
       </p:sp>
       <p:sp>
         <p:nvSpPr>
-          <p:cNvPr id="16" name="TextBox 15"/>
+          <p:cNvPr id="16" name="rec_3_rationale"/>
           <p:cNvSpPr txBox="1"/>
           <p:nvPr/>
         </p:nvSpPr>
@@ -5040,7 +4995,7 @@
       </p:sp>
       <p:sp>
         <p:nvSpPr>
-          <p:cNvPr id="17" name="Rectangle 16"/>
+          <p:cNvPr id="17" name="rec_4_circle"/>
           <p:cNvSpPr/>
           <p:nvPr/>
         </p:nvSpPr>
@@ -5080,7 +5035,7 @@
       </p:sp>
       <p:sp>
         <p:nvSpPr>
-          <p:cNvPr id="18" name="TextBox 17"/>
+          <p:cNvPr id="18" name="rec_4_num"/>
           <p:cNvSpPr txBox="1"/>
           <p:nvPr/>
         </p:nvSpPr>
@@ -5115,7 +5070,7 @@
       </p:sp>
       <p:sp>
         <p:nvSpPr>
-          <p:cNvPr id="19" name="TextBox 18"/>
+          <p:cNvPr id="19" name="rec_4_title"/>
           <p:cNvSpPr txBox="1"/>
           <p:nvPr/>
         </p:nvSpPr>
@@ -5150,7 +5105,7 @@
       </p:sp>
       <p:sp>
         <p:nvSpPr>
-          <p:cNvPr id="20" name="TextBox 19"/>
+          <p:cNvPr id="20" name="rec_4_rationale"/>
           <p:cNvSpPr txBox="1"/>
           <p:nvPr/>
         </p:nvSpPr>
@@ -5185,7 +5140,7 @@
       </p:sp>
       <p:sp>
         <p:nvSpPr>
-          <p:cNvPr id="21" name="Rectangle 20"/>
+          <p:cNvPr id="21" name="rec_5_circle"/>
           <p:cNvSpPr/>
           <p:nvPr/>
         </p:nvSpPr>
@@ -5225,7 +5180,7 @@
       </p:sp>
       <p:sp>
         <p:nvSpPr>
-          <p:cNvPr id="22" name="TextBox 21"/>
+          <p:cNvPr id="22" name="rec_5_num"/>
           <p:cNvSpPr txBox="1"/>
           <p:nvPr/>
         </p:nvSpPr>
@@ -5260,7 +5215,7 @@
       </p:sp>
       <p:sp>
         <p:nvSpPr>
-          <p:cNvPr id="23" name="TextBox 22"/>
+          <p:cNvPr id="23" name="rec_5_title"/>
           <p:cNvSpPr txBox="1"/>
           <p:nvPr/>
         </p:nvSpPr>
@@ -5295,7 +5250,7 @@
       </p:sp>
       <p:sp>
         <p:nvSpPr>
-          <p:cNvPr id="24" name="TextBox 23"/>
+          <p:cNvPr id="24" name="rec_5_rationale"/>
           <p:cNvSpPr txBox="1"/>
           <p:nvPr/>
         </p:nvSpPr>
@@ -5330,7 +5285,7 @@
       </p:sp>
       <p:sp>
         <p:nvSpPr>
-          <p:cNvPr id="25" name="Rectangle 24"/>
+          <p:cNvPr id="25" name="rec_6_circle"/>
           <p:cNvSpPr/>
           <p:nvPr/>
         </p:nvSpPr>
@@ -5370,7 +5325,7 @@
       </p:sp>
       <p:sp>
         <p:nvSpPr>
-          <p:cNvPr id="26" name="TextBox 25"/>
+          <p:cNvPr id="26" name="rec_6_num"/>
           <p:cNvSpPr txBox="1"/>
           <p:nvPr/>
         </p:nvSpPr>
@@ -5405,7 +5360,7 @@
       </p:sp>
       <p:sp>
         <p:nvSpPr>
-          <p:cNvPr id="27" name="TextBox 26"/>
+          <p:cNvPr id="27" name="rec_6_title"/>
           <p:cNvSpPr txBox="1"/>
           <p:nvPr/>
         </p:nvSpPr>
@@ -5440,7 +5395,7 @@
       </p:sp>
       <p:sp>
         <p:nvSpPr>
-          <p:cNvPr id="28" name="TextBox 27"/>
+          <p:cNvPr id="28" name="rec_6_rationale"/>
           <p:cNvSpPr txBox="1"/>
           <p:nvPr/>
         </p:nvSpPr>
@@ -5475,7 +5430,7 @@
       </p:sp>
       <p:sp>
         <p:nvSpPr>
-          <p:cNvPr id="29" name="Rectangle 28"/>
+          <p:cNvPr id="29" name="rec_7_circle"/>
           <p:cNvSpPr/>
           <p:nvPr/>
         </p:nvSpPr>
@@ -5515,7 +5470,7 @@
       </p:sp>
       <p:sp>
         <p:nvSpPr>
-          <p:cNvPr id="30" name="TextBox 29"/>
+          <p:cNvPr id="30" name="rec_7_num"/>
           <p:cNvSpPr txBox="1"/>
           <p:nvPr/>
         </p:nvSpPr>
@@ -5550,7 +5505,7 @@
       </p:sp>
       <p:sp>
         <p:nvSpPr>
-          <p:cNvPr id="31" name="TextBox 30"/>
+          <p:cNvPr id="31" name="rec_7_title"/>
           <p:cNvSpPr txBox="1"/>
           <p:nvPr/>
         </p:nvSpPr>
@@ -5585,7 +5540,7 @@
       </p:sp>
       <p:sp>
         <p:nvSpPr>
-          <p:cNvPr id="32" name="TextBox 31"/>
+          <p:cNvPr id="32" name="rec_7_rationale"/>
           <p:cNvSpPr txBox="1"/>
           <p:nvPr/>
         </p:nvSpPr>
@@ -5620,7 +5575,7 @@
       </p:sp>
       <p:sp>
         <p:nvSpPr>
-          <p:cNvPr id="33" name="Rectangle 32"/>
+          <p:cNvPr id="33" name="rec_8_circle"/>
           <p:cNvSpPr/>
           <p:nvPr/>
         </p:nvSpPr>
@@ -5660,7 +5615,7 @@
       </p:sp>
       <p:sp>
         <p:nvSpPr>
-          <p:cNvPr id="34" name="TextBox 33"/>
+          <p:cNvPr id="34" name="rec_8_num"/>
           <p:cNvSpPr txBox="1"/>
           <p:nvPr/>
         </p:nvSpPr>
@@ -5695,7 +5650,7 @@
       </p:sp>
       <p:sp>
         <p:nvSpPr>
-          <p:cNvPr id="35" name="TextBox 34"/>
+          <p:cNvPr id="35" name="rec_8_title"/>
           <p:cNvSpPr txBox="1"/>
           <p:nvPr/>
         </p:nvSpPr>
@@ -5730,7 +5685,7 @@
       </p:sp>
       <p:sp>
         <p:nvSpPr>
-          <p:cNvPr id="36" name="TextBox 35"/>
+          <p:cNvPr id="36" name="rec_8_rationale"/>
           <p:cNvSpPr txBox="1"/>
           <p:nvPr/>
         </p:nvSpPr>
@@ -5765,7 +5720,7 @@
       </p:sp>
       <p:sp>
         <p:nvSpPr>
-          <p:cNvPr id="37" name="Rectangle 36"/>
+          <p:cNvPr id="37" name="rec_9_circle"/>
           <p:cNvSpPr/>
           <p:nvPr/>
         </p:nvSpPr>
@@ -5805,7 +5760,7 @@
       </p:sp>
       <p:sp>
         <p:nvSpPr>
-          <p:cNvPr id="38" name="TextBox 37"/>
+          <p:cNvPr id="38" name="rec_9_num"/>
           <p:cNvSpPr txBox="1"/>
           <p:nvPr/>
         </p:nvSpPr>
@@ -5840,7 +5795,7 @@
       </p:sp>
       <p:sp>
         <p:nvSpPr>
-          <p:cNvPr id="39" name="TextBox 38"/>
+          <p:cNvPr id="39" name="rec_9_title"/>
           <p:cNvSpPr txBox="1"/>
           <p:nvPr/>
         </p:nvSpPr>
@@ -5875,7 +5830,7 @@
       </p:sp>
       <p:sp>
         <p:nvSpPr>
-          <p:cNvPr id="40" name="TextBox 39"/>
+          <p:cNvPr id="40" name="rec_9_rationale"/>
           <p:cNvSpPr txBox="1"/>
           <p:nvPr/>
         </p:nvSpPr>
@@ -5910,7 +5865,7 @@
       </p:sp>
       <p:sp>
         <p:nvSpPr>
-          <p:cNvPr id="41" name="Rectangle 40"/>
+          <p:cNvPr id="41" name="rec_10_circle"/>
           <p:cNvSpPr/>
           <p:nvPr/>
         </p:nvSpPr>
@@ -5950,7 +5905,7 @@
       </p:sp>
       <p:sp>
         <p:nvSpPr>
-          <p:cNvPr id="42" name="TextBox 41"/>
+          <p:cNvPr id="42" name="rec_10_num"/>
           <p:cNvSpPr txBox="1"/>
           <p:nvPr/>
         </p:nvSpPr>
@@ -5985,7 +5940,7 @@
       </p:sp>
       <p:sp>
         <p:nvSpPr>
-          <p:cNvPr id="43" name="TextBox 42"/>
+          <p:cNvPr id="43" name="rec_10_title"/>
           <p:cNvSpPr txBox="1"/>
           <p:nvPr/>
         </p:nvSpPr>
@@ -6020,7 +5975,7 @@
       </p:sp>
       <p:sp>
         <p:nvSpPr>
-          <p:cNvPr id="44" name="TextBox 43"/>
+          <p:cNvPr id="44" name="rec_10_rationale"/>
           <p:cNvSpPr txBox="1"/>
           <p:nvPr/>
         </p:nvSpPr>

</xml_diff>